<commit_message>
Ppt with use case , proposed system, data dictionary
</commit_message>
<xml_diff>
--- a/Documentation/AttendEase_Updated_Proposed_System.pptx
+++ b/Documentation/AttendEase_Updated_Proposed_System.pptx
@@ -25,7 +25,9 @@
     <p:sldId id="273" r:id="rId19"/>
     <p:sldId id="274" r:id="rId20"/>
     <p:sldId id="275" r:id="rId21"/>
-    <p:sldId id="264" r:id="rId22"/>
+    <p:sldId id="278" r:id="rId22"/>
+    <p:sldId id="279" r:id="rId23"/>
+    <p:sldId id="264" r:id="rId24"/>
   </p:sldIdLst>
   <p:sldSz cx="12192000" cy="6858000"/>
   <p:notesSz cx="6858000" cy="9144000"/>
@@ -11831,6 +11833,132 @@
 <file path=ppt/slides/slide21.xml><?xml version="1.0" encoding="utf-8"?>
 <p:sld xmlns:a="http://schemas.openxmlformats.org/drawingml/2006/main" xmlns:r="http://schemas.openxmlformats.org/officeDocument/2006/relationships" xmlns:p="http://schemas.openxmlformats.org/presentationml/2006/main">
   <p:cSld>
+    <p:spTree>
+      <p:nvGrpSpPr>
+        <p:cNvPr id="1" name=""/>
+        <p:cNvGrpSpPr/>
+        <p:nvPr/>
+      </p:nvGrpSpPr>
+      <p:grpSpPr>
+        <a:xfrm>
+          <a:off x="0" y="0"/>
+          <a:ext cx="0" cy="0"/>
+          <a:chOff x="0" y="0"/>
+          <a:chExt cx="0" cy="0"/>
+        </a:xfrm>
+      </p:grpSpPr>
+      <p:sp>
+        <p:nvSpPr>
+          <p:cNvPr id="2" name="Title 1">
+            <a:extLst>
+              <a:ext uri="{FF2B5EF4-FFF2-40B4-BE49-F238E27FC236}">
+                <a16:creationId xmlns:a16="http://schemas.microsoft.com/office/drawing/2014/main" id="{2C4510A6-796D-0060-C080-8C41CDA52CCC}"/>
+              </a:ext>
+            </a:extLst>
+          </p:cNvPr>
+          <p:cNvSpPr>
+            <a:spLocks noGrp="1"/>
+          </p:cNvSpPr>
+          <p:nvPr>
+            <p:ph type="title"/>
+          </p:nvPr>
+        </p:nvSpPr>
+        <p:spPr>
+          <a:xfrm>
+            <a:off x="990600" y="2531269"/>
+            <a:ext cx="10010775" cy="1969294"/>
+          </a:xfrm>
+        </p:spPr>
+        <p:txBody>
+          <a:bodyPr anchor="ctr">
+            <a:normAutofit/>
+          </a:bodyPr>
+          <a:lstStyle/>
+          <a:p>
+            <a:pPr algn="ctr"/>
+            <a:r>
+              <a:rPr lang="en-US" sz="6000" b="1"/>
+              <a:t>Use Case Diagram </a:t>
+            </a:r>
+          </a:p>
+        </p:txBody>
+      </p:sp>
+    </p:spTree>
+    <p:extLst>
+      <p:ext uri="{BB962C8B-B14F-4D97-AF65-F5344CB8AC3E}">
+        <p14:creationId xmlns:p14="http://schemas.microsoft.com/office/powerpoint/2010/main" val="309162497"/>
+      </p:ext>
+    </p:extLst>
+  </p:cSld>
+  <p:clrMapOvr>
+    <a:masterClrMapping/>
+  </p:clrMapOvr>
+</p:sld>
+</file>
+
+<file path=ppt/slides/slide22.xml><?xml version="1.0" encoding="utf-8"?>
+<p:sld xmlns:a="http://schemas.openxmlformats.org/drawingml/2006/main" xmlns:r="http://schemas.openxmlformats.org/officeDocument/2006/relationships" xmlns:p="http://schemas.openxmlformats.org/presentationml/2006/main">
+  <p:cSld>
+    <p:spTree>
+      <p:nvGrpSpPr>
+        <p:cNvPr id="1" name=""/>
+        <p:cNvGrpSpPr/>
+        <p:nvPr/>
+      </p:nvGrpSpPr>
+      <p:grpSpPr>
+        <a:xfrm>
+          <a:off x="0" y="0"/>
+          <a:ext cx="0" cy="0"/>
+          <a:chOff x="0" y="0"/>
+          <a:chExt cx="0" cy="0"/>
+        </a:xfrm>
+      </p:grpSpPr>
+      <p:pic>
+        <p:nvPicPr>
+          <p:cNvPr id="3" name="Picture 2">
+            <a:extLst>
+              <a:ext uri="{FF2B5EF4-FFF2-40B4-BE49-F238E27FC236}">
+                <a16:creationId xmlns:a16="http://schemas.microsoft.com/office/drawing/2014/main" id="{CB975F82-1361-A0C5-9D9A-1A29C0AF209E}"/>
+              </a:ext>
+            </a:extLst>
+          </p:cNvPr>
+          <p:cNvPicPr>
+            <a:picLocks noChangeAspect="1"/>
+          </p:cNvPicPr>
+          <p:nvPr/>
+        </p:nvPicPr>
+        <p:blipFill>
+          <a:blip r:embed="rId2"/>
+          <a:stretch>
+            <a:fillRect/>
+          </a:stretch>
+        </p:blipFill>
+        <p:spPr>
+          <a:xfrm>
+            <a:off x="1172767" y="196453"/>
+            <a:ext cx="10697766" cy="6465093"/>
+          </a:xfrm>
+          <a:prstGeom prst="rect">
+            <a:avLst/>
+          </a:prstGeom>
+        </p:spPr>
+      </p:pic>
+    </p:spTree>
+    <p:extLst>
+      <p:ext uri="{BB962C8B-B14F-4D97-AF65-F5344CB8AC3E}">
+        <p14:creationId xmlns:p14="http://schemas.microsoft.com/office/powerpoint/2010/main" val="4031529784"/>
+      </p:ext>
+    </p:extLst>
+  </p:cSld>
+  <p:clrMapOvr>
+    <a:masterClrMapping/>
+  </p:clrMapOvr>
+</p:sld>
+</file>
+
+<file path=ppt/slides/slide23.xml><?xml version="1.0" encoding="utf-8"?>
+<p:sld xmlns:a="http://schemas.openxmlformats.org/drawingml/2006/main" xmlns:r="http://schemas.openxmlformats.org/officeDocument/2006/relationships" xmlns:p="http://schemas.openxmlformats.org/presentationml/2006/main">
+  <p:cSld>
     <p:bg>
       <p:bgPr>
         <a:solidFill>
@@ -13800,7 +13928,7 @@
         <p:spPr>
           <a:xfrm>
             <a:off x="1104900" y="152400"/>
-            <a:ext cx="10058400" cy="6497782"/>
+            <a:ext cx="9884569" cy="6497782"/>
           </a:xfrm>
           <a:prstGeom prst="rect">
             <a:avLst/>

</xml_diff>